<commit_message>
classify document  and docs
</commit_message>
<xml_diff>
--- a/docs/PourAccord_PitchDeck_v2.pptx
+++ b/docs/PourAccord_PitchDeck_v2.pptx
@@ -2340,7 +2340,7 @@
               <a:buNone/>
             </a:pPr>
             <a:r>
-              <a:rPr lang="en-US" sz="1300" b="1" dirty="0">
+              <a:rPr lang="fr-FR" sz="1300" b="1" dirty="0">
                 <a:solidFill>
                   <a:srgbClr val="0D2137"/>
                 </a:solidFill>
@@ -2348,9 +2348,9 @@
                 <a:ea typeface="Calibri" pitchFamily="34" charset="-122"/>
                 <a:cs typeface="Calibri" pitchFamily="34" charset="-120"/>
               </a:rPr>
-              <a:t>30 min minimum</a:t>
-            </a:r>
-            <a:endParaRPr lang="en-US" sz="1300" dirty="0"/>
+              <a:t>30 min en moyenne</a:t>
+            </a:r>
+            <a:endParaRPr lang="fr-FR" sz="1300" dirty="0"/>
           </a:p>
         </p:txBody>
       </p:sp>
@@ -2877,7 +2877,7 @@
               <a:buNone/>
             </a:pPr>
             <a:r>
-              <a:rPr lang="en-US" sz="1100" dirty="0">
+              <a:rPr lang="fr-FR" sz="1100" dirty="0">
                 <a:solidFill>
                   <a:srgbClr val="64748B"/>
                 </a:solidFill>
@@ -2887,14 +2887,12 @@
               </a:rPr>
               <a:t>Stockage prolongé de données</a:t>
             </a:r>
-            <a:endParaRPr lang="en-US" sz="1100" dirty="0"/>
-          </a:p>
-          <a:p>
-            <a:pPr marL="0" indent="0">
-              <a:buNone/>
-            </a:pPr>
-            <a:r>
-              <a:rPr lang="en-US" sz="1100" dirty="0">
+            <a:r>
+              <a:rPr lang="fr-FR" sz="1100" dirty="0"/>
+              <a:t> </a:t>
+            </a:r>
+            <a:r>
+              <a:rPr lang="fr-FR" sz="1100" dirty="0">
                 <a:solidFill>
                   <a:srgbClr val="64748B"/>
                 </a:solidFill>
@@ -2904,7 +2902,7 @@
               </a:rPr>
               <a:t>personnelles sensibles</a:t>
             </a:r>
-            <a:endParaRPr lang="en-US" sz="1100" dirty="0"/>
+            <a:endParaRPr lang="fr-FR" sz="1100" dirty="0"/>
           </a:p>
         </p:txBody>
       </p:sp>
@@ -2917,7 +2915,7 @@
         <p:spPr>
           <a:xfrm>
             <a:off x="457200" y="3772129"/>
-            <a:ext cx="4155948" cy="1157963"/>
+            <a:ext cx="4224300" cy="1157963"/>
           </a:xfrm>
           <a:prstGeom prst="rect">
             <a:avLst/>
@@ -3072,7 +3070,7 @@
               <a:buNone/>
             </a:pPr>
             <a:r>
-              <a:rPr lang="en-US" sz="1050" i="1" dirty="0" err="1">
+              <a:rPr lang="fr-FR" sz="1050" i="1" dirty="0">
                 <a:solidFill>
                   <a:srgbClr val="FFFFFF"/>
                 </a:solidFill>
@@ -4900,7 +4898,7 @@
               <a:t>Suppression </a:t>
             </a:r>
             <a:r>
-              <a:rPr lang="en-US" sz="1050" dirty="0" err="1">
+              <a:rPr lang="fr-FR" sz="1050" dirty="0">
                 <a:solidFill>
                   <a:srgbClr val="64748B"/>
                 </a:solidFill>
@@ -7299,7 +7297,9 @@
           <a:prstGeom prst="rect">
             <a:avLst/>
           </a:prstGeom>
-          <a:noFill/>
+          <a:solidFill>
+            <a:srgbClr val="0C2136"/>
+          </a:solidFill>
           <a:ln/>
         </p:spPr>
         <p:txBody>
@@ -7431,7 +7431,9 @@
           <a:prstGeom prst="rect">
             <a:avLst/>
           </a:prstGeom>
-          <a:noFill/>
+          <a:solidFill>
+            <a:srgbClr val="0C2136"/>
+          </a:solidFill>
           <a:ln/>
         </p:spPr>
         <p:txBody>
@@ -7563,7 +7565,9 @@
           <a:prstGeom prst="rect">
             <a:avLst/>
           </a:prstGeom>
-          <a:noFill/>
+          <a:solidFill>
+            <a:srgbClr val="0C2136"/>
+          </a:solidFill>
           <a:ln/>
         </p:spPr>
         <p:txBody>
@@ -7655,7 +7659,7 @@
                   <a:srgbClr val="64748B"/>
                 </a:solidFill>
               </a:rPr>
-              <a:t>NIR, SIRET, MRZ vérifiés algorithmiquement</a:t>
+              <a:t>Ex : NIR, SIRET, MRZ… vérifiés algorithmiquement</a:t>
             </a:r>
             <a:endParaRPr lang="en-US" sz="1000" dirty="0"/>
           </a:p>
@@ -7695,7 +7699,9 @@
           <a:prstGeom prst="rect">
             <a:avLst/>
           </a:prstGeom>
-          <a:noFill/>
+          <a:solidFill>
+            <a:srgbClr val="0C2136"/>
+          </a:solidFill>
           <a:ln/>
         </p:spPr>
         <p:txBody>
@@ -7787,7 +7793,7 @@
                   <a:srgbClr val="64748B"/>
                 </a:solidFill>
               </a:rPr>
-              <a:t>Existence entreprise via API INSEE</a:t>
+              <a:t>Ex : Existence entreprise via API INSEE</a:t>
             </a:r>
             <a:endParaRPr lang="en-US" sz="1000" dirty="0"/>
           </a:p>
@@ -7827,7 +7833,9 @@
           <a:prstGeom prst="rect">
             <a:avLst/>
           </a:prstGeom>
-          <a:noFill/>
+          <a:solidFill>
+            <a:srgbClr val="0C2136"/>
+          </a:solidFill>
           <a:ln/>
         </p:spPr>
         <p:txBody>
@@ -7919,9 +7927,22 @@
                   <a:srgbClr val="64748B"/>
                 </a:solidFill>
               </a:rPr>
-              <a:t>Données cohérentes au sein d'un document</a:t>
-            </a:r>
-            <a:endParaRPr lang="en-US" sz="1000" dirty="0"/>
+              <a:t>Données cohérentes au sein d'un document </a:t>
+            </a:r>
+          </a:p>
+          <a:p>
+            <a:pPr marL="0" indent="0">
+              <a:buNone/>
+            </a:pPr>
+            <a:r>
+              <a:rPr lang="fr-FR" sz="800" dirty="0">
+                <a:solidFill>
+                  <a:srgbClr val="64748B"/>
+                </a:solidFill>
+              </a:rPr>
+              <a:t>Ex : cohérence des montants de la fiche de salaire</a:t>
+            </a:r>
+            <a:endParaRPr lang="fr-FR" sz="800" dirty="0"/>
           </a:p>
         </p:txBody>
       </p:sp>
@@ -7959,7 +7980,9 @@
           <a:prstGeom prst="rect">
             <a:avLst/>
           </a:prstGeom>
-          <a:noFill/>
+          <a:solidFill>
+            <a:srgbClr val="0C2136"/>
+          </a:solidFill>
           <a:ln/>
         </p:spPr>
         <p:txBody>
@@ -8091,7 +8114,9 @@
           <a:prstGeom prst="rect">
             <a:avLst/>
           </a:prstGeom>
-          <a:noFill/>
+          <a:solidFill>
+            <a:srgbClr val="0C2136"/>
+          </a:solidFill>
           <a:ln/>
         </p:spPr>
         <p:txBody>
@@ -8178,14 +8203,14 @@
               <a:buNone/>
             </a:pPr>
             <a:r>
-              <a:rPr lang="en-US" sz="1000" dirty="0">
+              <a:rPr lang="fr-FR" sz="1000" dirty="0">
                 <a:solidFill>
                   <a:srgbClr val="64748B"/>
                 </a:solidFill>
               </a:rPr>
-              <a:t>Détection métadonnées et altérations suspectes</a:t>
-            </a:r>
-            <a:endParaRPr lang="en-US" sz="1000" dirty="0"/>
+              <a:t>Détection métadonnées et altérations suspectes des documents</a:t>
+            </a:r>
+            <a:endParaRPr lang="fr-FR" sz="1000" dirty="0"/>
           </a:p>
         </p:txBody>
       </p:sp>
@@ -8198,7 +8223,7 @@
 </file>
 
 <file path=ppt/slides/slide7.xml><?xml version="1.0" encoding="utf-8"?>
-<p:sld xmlns:a="http://schemas.openxmlformats.org/drawingml/2006/main" xmlns:r="http://schemas.openxmlformats.org/officeDocument/2006/relationships" xmlns:p="http://schemas.openxmlformats.org/presentationml/2006/main">
+<p:sld xmlns:a="http://schemas.openxmlformats.org/drawingml/2006/main" xmlns:r="http://schemas.openxmlformats.org/officeDocument/2006/relationships" xmlns:p="http://schemas.openxmlformats.org/presentationml/2006/main" show="0">
   <p:cSld name="Slide 7">
     <p:bg>
       <p:bgPr>
@@ -9987,7 +10012,62 @@
                 <a:ea typeface="Calibri" pitchFamily="34" charset="-122"/>
                 <a:cs typeface="Calibri" pitchFamily="34" charset="-120"/>
               </a:rPr>
-              <a:t>De la beta à la plateforme de référence</a:t>
+              <a:t>De la beta </a:t>
+            </a:r>
+            <a:r>
+              <a:rPr lang="en-US" sz="2400" b="1" dirty="0" err="1">
+                <a:solidFill>
+                  <a:srgbClr val="FFFFFF"/>
+                </a:solidFill>
+                <a:latin typeface="Calibri" pitchFamily="34" charset="0"/>
+                <a:ea typeface="Calibri" pitchFamily="34" charset="-122"/>
+                <a:cs typeface="Calibri" pitchFamily="34" charset="-120"/>
+              </a:rPr>
+              <a:t>à</a:t>
+            </a:r>
+            <a:r>
+              <a:rPr lang="en-US" sz="2400" b="1" dirty="0">
+                <a:solidFill>
+                  <a:srgbClr val="FFFFFF"/>
+                </a:solidFill>
+                <a:latin typeface="Calibri" pitchFamily="34" charset="0"/>
+                <a:ea typeface="Calibri" pitchFamily="34" charset="-122"/>
+                <a:cs typeface="Calibri" pitchFamily="34" charset="-120"/>
+              </a:rPr>
+              <a:t> la </a:t>
+            </a:r>
+            <a:r>
+              <a:rPr lang="en-US" sz="2400" b="1" dirty="0" err="1">
+                <a:solidFill>
+                  <a:srgbClr val="FFFFFF"/>
+                </a:solidFill>
+                <a:latin typeface="Calibri" pitchFamily="34" charset="0"/>
+                <a:ea typeface="Calibri" pitchFamily="34" charset="-122"/>
+                <a:cs typeface="Calibri" pitchFamily="34" charset="-120"/>
+              </a:rPr>
+              <a:t>plateforme</a:t>
+            </a:r>
+            <a:r>
+              <a:rPr lang="en-US" sz="2400" b="1" dirty="0">
+                <a:solidFill>
+                  <a:srgbClr val="FFFFFF"/>
+                </a:solidFill>
+                <a:latin typeface="Calibri" pitchFamily="34" charset="0"/>
+                <a:ea typeface="Calibri" pitchFamily="34" charset="-122"/>
+                <a:cs typeface="Calibri" pitchFamily="34" charset="-120"/>
+              </a:rPr>
+              <a:t> de </a:t>
+            </a:r>
+            <a:r>
+              <a:rPr lang="en-US" sz="2400" b="1" dirty="0" err="1">
+                <a:solidFill>
+                  <a:srgbClr val="FFFFFF"/>
+                </a:solidFill>
+                <a:latin typeface="Calibri" pitchFamily="34" charset="0"/>
+                <a:ea typeface="Calibri" pitchFamily="34" charset="-122"/>
+                <a:cs typeface="Calibri" pitchFamily="34" charset="-120"/>
+              </a:rPr>
+              <a:t>référence</a:t>
             </a:r>
             <a:endParaRPr lang="en-US" sz="2400" dirty="0"/>
           </a:p>
@@ -11592,6 +11672,45 @@
               <a:t>International</a:t>
             </a:r>
             <a:endParaRPr lang="en-US" sz="1050" dirty="0"/>
+          </a:p>
+        </p:txBody>
+      </p:sp>
+      <p:sp>
+        <p:nvSpPr>
+          <p:cNvPr id="60" name="ZoneTexte 59">
+            <a:extLst>
+              <a:ext uri="{FF2B5EF4-FFF2-40B4-BE49-F238E27FC236}">
+                <a16:creationId xmlns:a16="http://schemas.microsoft.com/office/drawing/2014/main" id="{702FA9E2-417D-9CCC-3C3B-1F7A7A9B7A8F}"/>
+              </a:ext>
+            </a:extLst>
+          </p:cNvPr>
+          <p:cNvSpPr txBox="1"/>
+          <p:nvPr/>
+        </p:nvSpPr>
+        <p:spPr>
+          <a:xfrm rot="19656771">
+            <a:off x="865830" y="1228300"/>
+            <a:ext cx="6991722" cy="2215991"/>
+          </a:xfrm>
+          <a:prstGeom prst="rect">
+            <a:avLst/>
+          </a:prstGeom>
+          <a:noFill/>
+        </p:spPr>
+        <p:txBody>
+          <a:bodyPr wrap="none" rtlCol="0">
+            <a:spAutoFit/>
+          </a:bodyPr>
+          <a:lstStyle/>
+          <a:p>
+            <a:r>
+              <a:rPr lang="fr-FR" sz="13800" dirty="0">
+                <a:solidFill>
+                  <a:schemeClr val="bg1"/>
+                </a:solidFill>
+              </a:rPr>
+              <a:t>A REVOIR</a:t>
+            </a:r>
           </a:p>
         </p:txBody>
       </p:sp>

</xml_diff>